<commit_message>
Submit bge-base result (NDCG@10 0.06959), list both full runs
- configs/default.json uses bge-base, the model behind the submitted results file
- run_summary.json from the bge-base run on a teammate's Windows laptop, CPU only
- runs/ keeps the summary of every full run; README says the model was picked on the test split
- deck and AI disclosure name BAAI/bge-base-en-v1.5 and show the new scores
- demo_output.txt regenerated with bge-base
</commit_message>
<xml_diff>
--- a/submission/VITV_Procrastinators_Submission.pptx
+++ b/submission/VITV_Procrastinators_Submission.pptx
@@ -18907,7 +18907,7 @@
                 </a:solidFill>
                 <a:latin typeface="Calibri"/>
               </a:rPr>
-              <a:t>bge-small-en-v1.5</a:t>
+              <a:t>bge-base-en-v1.5</a:t>
             </a:r>
           </a:p>
           <a:p>
@@ -20725,7 +20725,7 @@
                 </a:solidFill>
                 <a:latin typeface="Calibri"/>
               </a:rPr>
-              <a:t>BAAI/bge-small-en-v1.5, pretrained, not fine tuned</a:t>
+              <a:t>BAAI/bge-base-en-v1.5, pretrained, not fine tuned</a:t>
             </a:r>
           </a:p>
           <a:p>
@@ -22514,7 +22514,7 @@
                 </a:solidFill>
                 <a:latin typeface="Calibri"/>
               </a:rPr>
-              <a:t>0.06698</a:t>
+              <a:t>0.06959</a:t>
             </a:r>
           </a:p>
         </p:txBody>
@@ -22584,7 +22584,7 @@
                 </a:solidFill>
                 <a:latin typeface="Calibri"/>
               </a:rPr>
-              <a:t>0.057086</a:t>
+              <a:t>0.05843</a:t>
             </a:r>
           </a:p>
         </p:txBody>
@@ -22619,7 +22619,7 @@
                 </a:solidFill>
                 <a:latin typeface="Calibri"/>
               </a:rPr>
-              <a:t>CoIR apps test split, full corpus: 8,765 documents, 3,765 queries. Whole run 359.3 s on 10 CPU cores.</a:t>
+              <a:t>CoIR apps test split, full corpus: 8,765 documents, 3,765 queries. Whole run 3051.7 s on 24 CPU cores. Best of two models run on this split.</a:t>
             </a:r>
           </a:p>
         </p:txBody>

</xml_diff>

<commit_message>
Point the demo video link to the final version with voiceover
</commit_message>
<xml_diff>
--- a/submission/VITV_Procrastinators_Submission.pptx
+++ b/submission/VITV_Procrastinators_Submission.pptx
@@ -15787,7 +15787,7 @@
                 </a:solidFill>
                 <a:latin typeface="Calibri"/>
               </a:rPr>
-              <a:t>https://drive.google.com/file/d/1FeSi1SZcfN0EnjjiQCgMNgergOchNoTL/view?usp=sharing</a:t>
+              <a:t>https://drive.google.com/file/d/1JIUAlqLvp3eXkVWTokDIGYVLuQ3Ivu-s/view?usp=sharing</a:t>
             </a:r>
           </a:p>
         </p:txBody>
@@ -20509,7 +20509,7 @@
                 </a:solidFill>
                 <a:latin typeface="Calibri"/>
               </a:rPr>
-              <a:t>Demo video: https://drive.google.com/file/d/1FeSi1SZcfN0EnjjiQCgMNgergOchNoTL/view?usp=sharing</a:t>
+              <a:t>Demo video: https://drive.google.com/file/d/1JIUAlqLvp3eXkVWTokDIGYVLuQ3Ivu-s/view?usp=sharing</a:t>
             </a:r>
           </a:p>
         </p:txBody>

</xml_diff>